<commit_message>
Docs: remove author attribution and prior-repo references
Drop the 'Author' line and the 'Reuse vs. rebuild' section from the write-up;
reframe source docstrings and the code walkthrough to describe the design on its
own terms (no references to a prior/internal repo). Remove author metadata and
byline from the deck. Regenerate the presentation.
</commit_message>
<xml_diff>
--- a/docs/RAG_Build_Break_Fix.pptx
+++ b/docs/RAG_Build_Break_Fix.pptx
@@ -2885,7 +2885,7 @@
                 <a:ea typeface="Calibri" pitchFamily="34" charset="-122"/>
                 <a:cs typeface="Calibri" pitchFamily="34" charset="-120"/>
               </a:rPr>
-              <a:t>NarenBabuR   ·   github.com/NarenBabuR/meraki</a:t>
+              <a:t>github.com/NarenBabuR/meraki</a:t>
             </a:r>
             <a:endParaRPr lang="en-US" sz="1300" dirty="0"/>
           </a:p>
@@ -10436,7 +10436,7 @@
                 <a:ea typeface="Trebuchet MS" pitchFamily="34" charset="-122"/>
                 <a:cs typeface="Trebuchet MS" pitchFamily="34" charset="-120"/>
               </a:rPr>
-              <a:t>Ported patterns, not infra</a:t>
+              <a:t>No cloud dependencies</a:t>
             </a:r>
             <a:endParaRPr lang="en-US" sz="1550" dirty="0"/>
           </a:p>
@@ -10475,7 +10475,7 @@
                 <a:ea typeface="Calibri" pitchFamily="34" charset="-122"/>
                 <a:cs typeface="Calibri" pitchFamily="34" charset="-120"/>
               </a:rPr>
-              <a:t>Reused chunking / two-stage retrieval / rerank ideas from a heavy prod repo — dropped AWS, Redis, SQS, paid PDF libs.</a:t>
+              <a:t>No AWS, Redis, SQS, S3, or paid PDF libraries — everything heavy runs locally and free, so it boots anywhere with one key.</a:t>
             </a:r>
             <a:endParaRPr lang="en-US" sz="1200" dirty="0"/>
           </a:p>

</xml_diff>